<commit_message>
修正 logo 比例、Mochiy Pop One 粗體、preview 流程
- Slide 1 & 11：logo 寬度從 3.18\" 修正為 0.715\"（保持高 0.38\" 等比縮放）
- Slide 5、6、7：移除 Mochiy Pop One 的 bold 設定（共 8 個 run）
- preview-pptx SKILL.md：改為用 preview_start 直接開啟 HTML 檔案路徑，
  不再使用 server.cjs，符合 Claude Code Desktop 內建 Preview 面板運作方式

Co-Authored-By: Claude Sonnet 4.6 <noreply@anthropic.com>
</commit_message>
<xml_diff>
--- a/guided/templates/pptx/通用簡報模板_TEMPLATE.pptx
+++ b/guided/templates/pptx/通用簡報模板_TEMPLATE.pptx
@@ -1008,7 +1008,7 @@
         <p:spPr>
           <a:xfrm>
             <a:off x="457200" y="4160520"/>
-            <a:ext cx="2907792" cy="347472"/>
+            <a:ext cx="653552" cy="347472"/>
           </a:xfrm>
           <a:prstGeom prst="rect">
             <a:avLst/>
@@ -1715,7 +1715,7 @@
         <p:spPr>
           <a:xfrm>
             <a:off x="457200" y="4160520"/>
-            <a:ext cx="2907792" cy="347472"/>
+            <a:ext cx="653552" cy="347472"/>
           </a:xfrm>
           <a:prstGeom prst="rect">
             <a:avLst/>
@@ -2823,7 +2823,7 @@
               <a:buNone/>
             </a:pPr>
             <a:r>
-              <a:rPr lang="en-US" sz="1800" b="1" dirty="0">
+              <a:rPr lang="en-US" sz="1800" b="0" dirty="0">
                 <a:solidFill>
                   <a:srgbClr val="FF5859"/>
                 </a:solidFill>
@@ -3014,7 +3014,7 @@
               <a:buNone/>
             </a:pPr>
             <a:r>
-              <a:rPr lang="en-US" sz="1800" b="1" dirty="0">
+              <a:rPr lang="en-US" sz="1800" b="0" dirty="0">
                 <a:solidFill>
                   <a:srgbClr val="FF5859"/>
                 </a:solidFill>
@@ -3205,7 +3205,7 @@
               <a:buNone/>
             </a:pPr>
             <a:r>
-              <a:rPr lang="en-US" sz="1800" b="1" dirty="0">
+              <a:rPr lang="en-US" sz="1800" b="0" dirty="0">
                 <a:solidFill>
                   <a:srgbClr val="FF5859"/>
                 </a:solidFill>
@@ -3400,7 +3400,7 @@
               <a:buNone/>
             </a:pPr>
             <a:r>
-              <a:rPr lang="en-US" sz="2800" b="1" dirty="0">
+              <a:rPr lang="en-US" sz="2800" b="0" dirty="0">
                 <a:solidFill>
                   <a:srgbClr val="FFFFFF"/>
                 </a:solidFill>
@@ -3758,7 +3758,7 @@
               <a:buNone/>
             </a:pPr>
             <a:r>
-              <a:rPr lang="en-US" sz="2200" b="1" dirty="0">
+              <a:rPr lang="en-US" sz="2200" b="0" dirty="0">
                 <a:solidFill>
                   <a:srgbClr val="FFFFFF"/>
                 </a:solidFill>
@@ -3962,7 +3962,7 @@
               <a:buNone/>
             </a:pPr>
             <a:r>
-              <a:rPr lang="en-US" sz="2200" b="1" dirty="0">
+              <a:rPr lang="en-US" sz="2200" b="0" dirty="0">
                 <a:solidFill>
                   <a:srgbClr val="FFFFFF"/>
                 </a:solidFill>
@@ -4166,7 +4166,7 @@
               <a:buNone/>
             </a:pPr>
             <a:r>
-              <a:rPr lang="en-US" sz="2200" b="1" dirty="0">
+              <a:rPr lang="en-US" sz="2200" b="0" dirty="0">
                 <a:solidFill>
                   <a:srgbClr val="FFFFFF"/>
                 </a:solidFill>
@@ -4370,7 +4370,7 @@
               <a:buNone/>
             </a:pPr>
             <a:r>
-              <a:rPr lang="en-US" sz="2200" b="1" dirty="0">
+              <a:rPr lang="en-US" sz="2200" b="0" dirty="0">
                 <a:solidFill>
                   <a:srgbClr val="FFFFFF"/>
                 </a:solidFill>

</xml_diff>